<commit_message>
Deck: the activity feed goes back in, now that it reads as English
It was left out of the phase 4b deck because it printed "maya:
occurrence_done". B-16 fixed that rather than cropping around it, so slide 5
carries it — including F4's diff broadcast, "Water the plants: schedule: every
3 days → every 4 days", which is the spec's own worked example and was not
legible in the app until today.

The handoff also records that the live server is now one commit behind: B-15
landed after the SSH rule closed. A query-ordering fix, no schema change, no
client dependency — take it with the next deploy.

Co-Authored-By: Claude Opus 5 <noreply@anthropic.com>
</commit_message>
<xml_diff>
--- a/TaskFlow_Screens.pptx
+++ b/TaskFlow_Screens.pptx
@@ -3462,7 +3462,7 @@
         </p:nvSpPr>
         <p:spPr>
           <a:xfrm>
-            <a:off x="2148840" y="1188720"/>
+            <a:off x="754380" y="1188720"/>
             <a:ext cx="2286000" cy="4937760"/>
           </a:xfrm>
           <a:prstGeom prst="roundRect">
@@ -3497,7 +3497,7 @@
         </p:blipFill>
         <p:spPr>
           <a:xfrm>
-            <a:off x="2263140" y="1353312"/>
+            <a:off x="868680" y="1353312"/>
             <a:ext cx="2057400" cy="4572000"/>
           </a:xfrm>
           <a:prstGeom prst="rect">
@@ -3520,7 +3520,7 @@
         </p:nvSpPr>
         <p:spPr>
           <a:xfrm>
-            <a:off x="2148840" y="6236208"/>
+            <a:off x="754380" y="6236208"/>
             <a:ext cx="2286000" cy="256032"/>
           </a:xfrm>
           <a:prstGeom prst="rect">
@@ -3559,7 +3559,7 @@
         </p:nvSpPr>
         <p:spPr>
           <a:xfrm>
-            <a:off x="2039112" y="6492240"/>
+            <a:off x="644652" y="6492240"/>
             <a:ext cx="2505456" cy="384048"/>
           </a:xfrm>
           <a:prstGeom prst="rect">
@@ -3598,7 +3598,7 @@
         </p:nvSpPr>
         <p:spPr>
           <a:xfrm>
-            <a:off x="4937760" y="1188720"/>
+            <a:off x="3543300" y="1188720"/>
             <a:ext cx="2286000" cy="4937760"/>
           </a:xfrm>
           <a:prstGeom prst="roundRect">
@@ -3633,7 +3633,7 @@
         </p:blipFill>
         <p:spPr>
           <a:xfrm>
-            <a:off x="5052060" y="1353312"/>
+            <a:off x="3657600" y="1353312"/>
             <a:ext cx="2057400" cy="4572000"/>
           </a:xfrm>
           <a:prstGeom prst="rect">
@@ -3656,7 +3656,7 @@
         </p:nvSpPr>
         <p:spPr>
           <a:xfrm>
-            <a:off x="4937760" y="6236208"/>
+            <a:off x="3543300" y="6236208"/>
             <a:ext cx="2286000" cy="256032"/>
           </a:xfrm>
           <a:prstGeom prst="rect">
@@ -3695,7 +3695,7 @@
         </p:nvSpPr>
         <p:spPr>
           <a:xfrm>
-            <a:off x="4828032" y="6492240"/>
+            <a:off x="3433572" y="6492240"/>
             <a:ext cx="2505456" cy="384048"/>
           </a:xfrm>
           <a:prstGeom prst="rect">
@@ -3734,7 +3734,7 @@
         </p:nvSpPr>
         <p:spPr>
           <a:xfrm>
-            <a:off x="7726680" y="1188720"/>
+            <a:off x="6332220" y="1188720"/>
             <a:ext cx="2286000" cy="4937760"/>
           </a:xfrm>
           <a:prstGeom prst="roundRect">
@@ -3755,7 +3755,7 @@
       </p:sp>
       <p:pic>
         <p:nvPicPr>
-          <p:cNvPr id="13" name="Image 2" descr="C:\Users\babak\AppData\Local\Temp\claude\D--0A-study-A0-0-ACSAI-0-sem-4-AI-ML-ML-unit-2\13f11f40-7bf3-4475-bdab-4aadda964c01\scratchpad\shots\13-quiet-hours.png">    </p:cNvPr>
+          <p:cNvPr id="13" name="Image 2" descr="C:\Users\babak\AppData\Local\Temp\claude\D--0A-study-A0-0-ACSAI-0-sem-4-AI-ML-ML-unit-2\13f11f40-7bf3-4475-bdab-4aadda964c01\scratchpad\shots\10-activity.png">    </p:cNvPr>
           <p:cNvPicPr>
             <a:picLocks noChangeAspect="1"/>
           </p:cNvPicPr>
@@ -3769,7 +3769,7 @@
         </p:blipFill>
         <p:spPr>
           <a:xfrm>
-            <a:off x="7840980" y="1353312"/>
+            <a:off x="6446520" y="1353312"/>
             <a:ext cx="2057400" cy="4572000"/>
           </a:xfrm>
           <a:prstGeom prst="rect">
@@ -3792,7 +3792,143 @@
         </p:nvSpPr>
         <p:spPr>
           <a:xfrm>
-            <a:off x="7726680" y="6236208"/>
+            <a:off x="6332220" y="6236208"/>
+            <a:ext cx="2286000" cy="256032"/>
+          </a:xfrm>
+          <a:prstGeom prst="rect">
+            <a:avLst/>
+          </a:prstGeom>
+          <a:noFill/>
+          <a:ln/>
+        </p:spPr>
+        <p:txBody>
+          <a:bodyPr wrap="square" lIns="0" tIns="0" rIns="0" bIns="0" rtlCol="0" anchor="ctr"/>
+          <a:lstStyle/>
+          <a:p>
+            <a:pPr algn="ctr" indent="0" marL="0">
+              <a:buNone/>
+            </a:pPr>
+            <a:r>
+              <a:rPr lang="en-US" sz="1200" b="1" dirty="0">
+                <a:solidFill>
+                  <a:srgbClr val="1A1B2E"/>
+                </a:solidFill>
+                <a:latin typeface="Calibri" pitchFamily="34" charset="0"/>
+                <a:ea typeface="Calibri" pitchFamily="34" charset="-122"/>
+                <a:cs typeface="Calibri" pitchFamily="34" charset="-120"/>
+              </a:rPr>
+              <a:t>Activity</a:t>
+            </a:r>
+            <a:endParaRPr lang="en-US" sz="1200" dirty="0"/>
+          </a:p>
+        </p:txBody>
+      </p:sp>
+      <p:sp>
+        <p:nvSpPr>
+          <p:cNvPr id="15" name="Text 10"/>
+          <p:cNvSpPr txBox="1"/>
+          <p:nvPr/>
+        </p:nvSpPr>
+        <p:spPr>
+          <a:xfrm>
+            <a:off x="6222492" y="6492240"/>
+            <a:ext cx="2505456" cy="384048"/>
+          </a:xfrm>
+          <a:prstGeom prst="rect">
+            <a:avLst/>
+          </a:prstGeom>
+          <a:noFill/>
+          <a:ln/>
+        </p:spPr>
+        <p:txBody>
+          <a:bodyPr wrap="square" lIns="0" tIns="0" rIns="0" bIns="0" rtlCol="0" anchor="ctr"/>
+          <a:lstStyle/>
+          <a:p>
+            <a:pPr algn="ctr" indent="0" marL="0">
+              <a:buNone/>
+            </a:pPr>
+            <a:r>
+              <a:rPr lang="en-US" sz="1000" dirty="0">
+                <a:solidFill>
+                  <a:srgbClr val="6B6F80"/>
+                </a:solidFill>
+                <a:latin typeface="Calibri" pitchFamily="34" charset="0"/>
+                <a:ea typeface="Calibri" pitchFamily="34" charset="-122"/>
+                <a:cs typeface="Calibri" pitchFamily="34" charset="-120"/>
+              </a:rPr>
+              <a:t>Every group-visible change, in words</a:t>
+            </a:r>
+            <a:endParaRPr lang="en-US" sz="1000" dirty="0"/>
+          </a:p>
+        </p:txBody>
+      </p:sp>
+      <p:sp>
+        <p:nvSpPr>
+          <p:cNvPr id="16" name="Shape 11"/>
+          <p:cNvSpPr/>
+          <p:nvPr/>
+        </p:nvSpPr>
+        <p:spPr>
+          <a:xfrm>
+            <a:off x="9121140" y="1188720"/>
+            <a:ext cx="2286000" cy="4937760"/>
+          </a:xfrm>
+          <a:prstGeom prst="roundRect">
+            <a:avLst>
+              <a:gd name="adj" fmla="val 4800"/>
+            </a:avLst>
+          </a:prstGeom>
+          <a:solidFill>
+            <a:srgbClr val="F4F5FA"/>
+          </a:solidFill>
+          <a:ln w="12700">
+            <a:solidFill>
+              <a:srgbClr val="E4E6F0"/>
+            </a:solidFill>
+            <a:prstDash val="solid"/>
+          </a:ln>
+        </p:spPr>
+      </p:sp>
+      <p:pic>
+        <p:nvPicPr>
+          <p:cNvPr id="17" name="Image 3" descr="C:\Users\babak\AppData\Local\Temp\claude\D--0A-study-A0-0-ACSAI-0-sem-4-AI-ML-ML-unit-2\13f11f40-7bf3-4475-bdab-4aadda964c01\scratchpad\shots\13-quiet-hours.png">    </p:cNvPr>
+          <p:cNvPicPr>
+            <a:picLocks noChangeAspect="1"/>
+          </p:cNvPicPr>
+          <p:nvPr/>
+        </p:nvPicPr>
+        <p:blipFill>
+          <a:blip r:embed="rId4"/>
+          <a:stretch>
+            <a:fillRect/>
+          </a:stretch>
+        </p:blipFill>
+        <p:spPr>
+          <a:xfrm>
+            <a:off x="9235440" y="1353312"/>
+            <a:ext cx="2057400" cy="4572000"/>
+          </a:xfrm>
+          <a:prstGeom prst="rect">
+            <a:avLst/>
+          </a:prstGeom>
+          <a:effectLst>
+            <a:outerShdw sx="100000" sy="100000" kx="0" ky="0" algn="bl" rotWithShape="0" blurRad="127000" dist="38100" dir="5400000">
+              <a:srgbClr val="1A1B2E">
+                <a:alpha val="22000"/>
+              </a:srgbClr>
+            </a:outerShdw>
+          </a:effectLst>
+        </p:spPr>
+      </p:pic>
+      <p:sp>
+        <p:nvSpPr>
+          <p:cNvPr id="18" name="Text 12"/>
+          <p:cNvSpPr txBox="1"/>
+          <p:nvPr/>
+        </p:nvSpPr>
+        <p:spPr>
+          <a:xfrm>
+            <a:off x="9121140" y="6236208"/>
             <a:ext cx="2286000" cy="256032"/>
           </a:xfrm>
           <a:prstGeom prst="rect">
@@ -3825,13 +3961,13 @@
       </p:sp>
       <p:sp>
         <p:nvSpPr>
-          <p:cNvPr id="15" name="Text 10"/>
+          <p:cNvPr id="19" name="Text 13"/>
           <p:cNvSpPr txBox="1"/>
           <p:nvPr/>
         </p:nvSpPr>
         <p:spPr>
           <a:xfrm>
-            <a:off x="7616952" y="6492240"/>
+            <a:off x="9011412" y="6492240"/>
             <a:ext cx="2505456" cy="384048"/>
           </a:xfrm>
           <a:prstGeom prst="rect">

</xml_diff>